<commit_message>
change figure 2 plotting order'
</commit_message>
<xml_diff>
--- a/figures/ch1_figures.pptx
+++ b/figures/ch1_figures.pptx
@@ -104,6 +104,11 @@
       </a:defRPr>
     </a:lvl9pPr>
   </p:defaultTextStyle>
+  <p:extLst>
+    <p:ext uri="{EFAFB233-063F-42B5-8137-9DF3F51BA10A}">
+      <p15:sldGuideLst xmlns:p15="http://schemas.microsoft.com/office/powerpoint/2012/main"/>
+    </p:ext>
+  </p:extLst>
 </p:presentation>
 </file>
 
@@ -254,7 +259,7 @@
           <a:p>
             <a:fld id="{6AECCEE4-E404-41DF-89A3-E64313283A40}" type="datetimeFigureOut">
               <a:rPr lang="en-US" smtClean="0"/>
-              <a:t>6/16/2026</a:t>
+              <a:t>6/17/2026</a:t>
             </a:fld>
             <a:endParaRPr lang="en-US"/>
           </a:p>
@@ -452,7 +457,7 @@
           <a:p>
             <a:fld id="{6AECCEE4-E404-41DF-89A3-E64313283A40}" type="datetimeFigureOut">
               <a:rPr lang="en-US" smtClean="0"/>
-              <a:t>6/16/2026</a:t>
+              <a:t>6/17/2026</a:t>
             </a:fld>
             <a:endParaRPr lang="en-US"/>
           </a:p>
@@ -660,7 +665,7 @@
           <a:p>
             <a:fld id="{6AECCEE4-E404-41DF-89A3-E64313283A40}" type="datetimeFigureOut">
               <a:rPr lang="en-US" smtClean="0"/>
-              <a:t>6/16/2026</a:t>
+              <a:t>6/17/2026</a:t>
             </a:fld>
             <a:endParaRPr lang="en-US"/>
           </a:p>
@@ -858,7 +863,7 @@
           <a:p>
             <a:fld id="{6AECCEE4-E404-41DF-89A3-E64313283A40}" type="datetimeFigureOut">
               <a:rPr lang="en-US" smtClean="0"/>
-              <a:t>6/16/2026</a:t>
+              <a:t>6/17/2026</a:t>
             </a:fld>
             <a:endParaRPr lang="en-US"/>
           </a:p>
@@ -1133,7 +1138,7 @@
           <a:p>
             <a:fld id="{6AECCEE4-E404-41DF-89A3-E64313283A40}" type="datetimeFigureOut">
               <a:rPr lang="en-US" smtClean="0"/>
-              <a:t>6/16/2026</a:t>
+              <a:t>6/17/2026</a:t>
             </a:fld>
             <a:endParaRPr lang="en-US"/>
           </a:p>
@@ -1398,7 +1403,7 @@
           <a:p>
             <a:fld id="{6AECCEE4-E404-41DF-89A3-E64313283A40}" type="datetimeFigureOut">
               <a:rPr lang="en-US" smtClean="0"/>
-              <a:t>6/16/2026</a:t>
+              <a:t>6/17/2026</a:t>
             </a:fld>
             <a:endParaRPr lang="en-US"/>
           </a:p>
@@ -1810,7 +1815,7 @@
           <a:p>
             <a:fld id="{6AECCEE4-E404-41DF-89A3-E64313283A40}" type="datetimeFigureOut">
               <a:rPr lang="en-US" smtClean="0"/>
-              <a:t>6/16/2026</a:t>
+              <a:t>6/17/2026</a:t>
             </a:fld>
             <a:endParaRPr lang="en-US"/>
           </a:p>
@@ -1951,7 +1956,7 @@
           <a:p>
             <a:fld id="{6AECCEE4-E404-41DF-89A3-E64313283A40}" type="datetimeFigureOut">
               <a:rPr lang="en-US" smtClean="0"/>
-              <a:t>6/16/2026</a:t>
+              <a:t>6/17/2026</a:t>
             </a:fld>
             <a:endParaRPr lang="en-US"/>
           </a:p>
@@ -2064,7 +2069,7 @@
           <a:p>
             <a:fld id="{6AECCEE4-E404-41DF-89A3-E64313283A40}" type="datetimeFigureOut">
               <a:rPr lang="en-US" smtClean="0"/>
-              <a:t>6/16/2026</a:t>
+              <a:t>6/17/2026</a:t>
             </a:fld>
             <a:endParaRPr lang="en-US"/>
           </a:p>
@@ -2375,7 +2380,7 @@
           <a:p>
             <a:fld id="{6AECCEE4-E404-41DF-89A3-E64313283A40}" type="datetimeFigureOut">
               <a:rPr lang="en-US" smtClean="0"/>
-              <a:t>6/16/2026</a:t>
+              <a:t>6/17/2026</a:t>
             </a:fld>
             <a:endParaRPr lang="en-US"/>
           </a:p>
@@ -2663,7 +2668,7 @@
           <a:p>
             <a:fld id="{6AECCEE4-E404-41DF-89A3-E64313283A40}" type="datetimeFigureOut">
               <a:rPr lang="en-US" smtClean="0"/>
-              <a:t>6/16/2026</a:t>
+              <a:t>6/17/2026</a:t>
             </a:fld>
             <a:endParaRPr lang="en-US"/>
           </a:p>
@@ -2904,7 +2909,7 @@
           <a:p>
             <a:fld id="{6AECCEE4-E404-41DF-89A3-E64313283A40}" type="datetimeFigureOut">
               <a:rPr lang="en-US" smtClean="0"/>
-              <a:t>6/16/2026</a:t>
+              <a:t>6/17/2026</a:t>
             </a:fld>
             <a:endParaRPr lang="en-US"/>
           </a:p>
@@ -3349,8 +3354,119 @@
         </p:blipFill>
         <p:spPr>
           <a:xfrm>
-            <a:off x="185486" y="1359569"/>
+            <a:off x="169720" y="1398984"/>
             <a:ext cx="11816515" cy="3938838"/>
+          </a:xfrm>
+          <a:prstGeom prst="rect">
+            <a:avLst/>
+          </a:prstGeom>
+        </p:spPr>
+      </p:pic>
+      <p:pic>
+        <p:nvPicPr>
+          <p:cNvPr id="22" name="Picture 21">
+            <a:extLst>
+              <a:ext uri="{FF2B5EF4-FFF2-40B4-BE49-F238E27FC236}">
+                <a16:creationId xmlns:a16="http://schemas.microsoft.com/office/drawing/2014/main" id="{CAB3B78F-717D-9F3A-650C-302735D40BE3}"/>
+              </a:ext>
+            </a:extLst>
+          </p:cNvPr>
+          <p:cNvPicPr>
+            <a:picLocks noChangeAspect="1"/>
+          </p:cNvPicPr>
+          <p:nvPr/>
+        </p:nvPicPr>
+        <p:blipFill>
+          <a:blip r:embed="rId2">
+            <a:extLst>
+              <a:ext uri="{28A0092B-C50C-407E-A947-70E740481C1C}">
+                <a14:useLocalDpi xmlns:a14="http://schemas.microsoft.com/office/drawing/2010/main" val="0"/>
+              </a:ext>
+            </a:extLst>
+          </a:blip>
+          <a:srcRect l="2676" r="67627"/>
+          <a:stretch>
+            <a:fillRect/>
+          </a:stretch>
+        </p:blipFill>
+        <p:spPr>
+          <a:xfrm>
+            <a:off x="4429579" y="1398983"/>
+            <a:ext cx="3508980" cy="3938838"/>
+          </a:xfrm>
+          <a:prstGeom prst="rect">
+            <a:avLst/>
+          </a:prstGeom>
+        </p:spPr>
+      </p:pic>
+      <p:pic>
+        <p:nvPicPr>
+          <p:cNvPr id="10" name="Picture 9">
+            <a:extLst>
+              <a:ext uri="{FF2B5EF4-FFF2-40B4-BE49-F238E27FC236}">
+                <a16:creationId xmlns:a16="http://schemas.microsoft.com/office/drawing/2014/main" id="{B915C65E-FCA2-5689-71B8-FFB6B54C22F2}"/>
+              </a:ext>
+            </a:extLst>
+          </p:cNvPr>
+          <p:cNvPicPr>
+            <a:picLocks noChangeAspect="1"/>
+          </p:cNvPicPr>
+          <p:nvPr/>
+        </p:nvPicPr>
+        <p:blipFill>
+          <a:blip r:embed="rId2">
+            <a:extLst>
+              <a:ext uri="{28A0092B-C50C-407E-A947-70E740481C1C}">
+                <a14:useLocalDpi xmlns:a14="http://schemas.microsoft.com/office/drawing/2010/main" val="0"/>
+              </a:ext>
+            </a:extLst>
+          </a:blip>
+          <a:srcRect l="69374" r="-3492"/>
+          <a:stretch>
+            <a:fillRect/>
+          </a:stretch>
+        </p:blipFill>
+        <p:spPr>
+          <a:xfrm>
+            <a:off x="510175" y="1398984"/>
+            <a:ext cx="4031501" cy="3938838"/>
+          </a:xfrm>
+          <a:prstGeom prst="rect">
+            <a:avLst/>
+          </a:prstGeom>
+        </p:spPr>
+      </p:pic>
+      <p:pic>
+        <p:nvPicPr>
+          <p:cNvPr id="3" name="Picture 2">
+            <a:extLst>
+              <a:ext uri="{FF2B5EF4-FFF2-40B4-BE49-F238E27FC236}">
+                <a16:creationId xmlns:a16="http://schemas.microsoft.com/office/drawing/2014/main" id="{19FC5159-39B3-15DB-D255-04AEF7AD3153}"/>
+              </a:ext>
+            </a:extLst>
+          </p:cNvPr>
+          <p:cNvPicPr>
+            <a:picLocks noChangeAspect="1"/>
+          </p:cNvPicPr>
+          <p:nvPr/>
+        </p:nvPicPr>
+        <p:blipFill>
+          <a:blip r:embed="rId2">
+            <a:extLst>
+              <a:ext uri="{28A0092B-C50C-407E-A947-70E740481C1C}">
+                <a14:useLocalDpi xmlns:a14="http://schemas.microsoft.com/office/drawing/2010/main" val="0"/>
+              </a:ext>
+            </a:extLst>
+          </a:blip>
+          <a:srcRect l="36035" r="31981"/>
+          <a:stretch>
+            <a:fillRect/>
+          </a:stretch>
+        </p:blipFill>
+        <p:spPr>
+          <a:xfrm>
+            <a:off x="8369224" y="1398983"/>
+            <a:ext cx="3779400" cy="3938838"/>
           </a:xfrm>
           <a:prstGeom prst="rect">
             <a:avLst/>
@@ -3450,43 +3566,6 @@
       </p:pic>
       <p:pic>
         <p:nvPicPr>
-          <p:cNvPr id="8" name="Picture 7">
-            <a:extLst>
-              <a:ext uri="{FF2B5EF4-FFF2-40B4-BE49-F238E27FC236}">
-                <a16:creationId xmlns:a16="http://schemas.microsoft.com/office/drawing/2014/main" id="{69F32806-A789-D6FA-9691-75CED68EA4CF}"/>
-              </a:ext>
-            </a:extLst>
-          </p:cNvPr>
-          <p:cNvPicPr>
-            <a:picLocks noChangeAspect="1"/>
-          </p:cNvPicPr>
-          <p:nvPr/>
-        </p:nvPicPr>
-        <p:blipFill>
-          <a:blip r:embed="rId2">
-            <a:extLst>
-              <a:ext uri="{28A0092B-C50C-407E-A947-70E740481C1C}">
-                <a14:useLocalDpi xmlns:a14="http://schemas.microsoft.com/office/drawing/2010/main" val="0"/>
-              </a:ext>
-            </a:extLst>
-          </a:blip>
-          <a:srcRect l="9164" t="85949" r="87484" b="8858"/>
-          <a:stretch>
-            <a:fillRect/>
-          </a:stretch>
-        </p:blipFill>
-        <p:spPr>
-          <a:xfrm>
-            <a:off x="4958015" y="4748452"/>
-            <a:ext cx="396040" cy="204537"/>
-          </a:xfrm>
-          <a:prstGeom prst="rect">
-            <a:avLst/>
-          </a:prstGeom>
-        </p:spPr>
-      </p:pic>
-      <p:pic>
-        <p:nvPicPr>
           <p:cNvPr id="11" name="Picture 10">
             <a:extLst>
               <a:ext uri="{FF2B5EF4-FFF2-40B4-BE49-F238E27FC236}">
@@ -3522,6 +3601,80 @@
           </a:prstGeom>
         </p:spPr>
       </p:pic>
+      <p:pic>
+        <p:nvPicPr>
+          <p:cNvPr id="15" name="Picture 14">
+            <a:extLst>
+              <a:ext uri="{FF2B5EF4-FFF2-40B4-BE49-F238E27FC236}">
+                <a16:creationId xmlns:a16="http://schemas.microsoft.com/office/drawing/2014/main" id="{06BC8448-7934-D504-ED85-3E54E07E26DB}"/>
+              </a:ext>
+            </a:extLst>
+          </p:cNvPr>
+          <p:cNvPicPr>
+            <a:picLocks noChangeAspect="1"/>
+          </p:cNvPicPr>
+          <p:nvPr/>
+        </p:nvPicPr>
+        <p:blipFill>
+          <a:blip r:embed="rId2">
+            <a:extLst>
+              <a:ext uri="{28A0092B-C50C-407E-A947-70E740481C1C}">
+                <a14:useLocalDpi xmlns:a14="http://schemas.microsoft.com/office/drawing/2010/main" val="0"/>
+              </a:ext>
+            </a:extLst>
+          </a:blip>
+          <a:srcRect t="77447" r="64775"/>
+          <a:stretch>
+            <a:fillRect/>
+          </a:stretch>
+        </p:blipFill>
+        <p:spPr>
+          <a:xfrm>
+            <a:off x="497305" y="5969668"/>
+            <a:ext cx="4162426" cy="888332"/>
+          </a:xfrm>
+          <a:prstGeom prst="rect">
+            <a:avLst/>
+          </a:prstGeom>
+        </p:spPr>
+      </p:pic>
+      <p:pic>
+        <p:nvPicPr>
+          <p:cNvPr id="8" name="Picture 7">
+            <a:extLst>
+              <a:ext uri="{FF2B5EF4-FFF2-40B4-BE49-F238E27FC236}">
+                <a16:creationId xmlns:a16="http://schemas.microsoft.com/office/drawing/2014/main" id="{69F32806-A789-D6FA-9691-75CED68EA4CF}"/>
+              </a:ext>
+            </a:extLst>
+          </p:cNvPr>
+          <p:cNvPicPr>
+            <a:picLocks noChangeAspect="1"/>
+          </p:cNvPicPr>
+          <p:nvPr/>
+        </p:nvPicPr>
+        <p:blipFill>
+          <a:blip r:embed="rId2">
+            <a:extLst>
+              <a:ext uri="{28A0092B-C50C-407E-A947-70E740481C1C}">
+                <a14:useLocalDpi xmlns:a14="http://schemas.microsoft.com/office/drawing/2010/main" val="0"/>
+              </a:ext>
+            </a:extLst>
+          </a:blip>
+          <a:srcRect l="9164" t="85949" r="87484" b="8858"/>
+          <a:stretch>
+            <a:fillRect/>
+          </a:stretch>
+        </p:blipFill>
+        <p:spPr>
+          <a:xfrm>
+            <a:off x="8886891" y="4796451"/>
+            <a:ext cx="396040" cy="204537"/>
+          </a:xfrm>
+          <a:prstGeom prst="rect">
+            <a:avLst/>
+          </a:prstGeom>
+        </p:spPr>
+      </p:pic>
       <p:grpSp>
         <p:nvGrpSpPr>
           <p:cNvPr id="13" name="Group 12">
@@ -3536,7 +3689,7 @@
         </p:nvGrpSpPr>
         <p:grpSpPr>
           <a:xfrm>
-            <a:off x="5278186" y="4751849"/>
+            <a:off x="9207062" y="4791965"/>
             <a:ext cx="553312" cy="204538"/>
             <a:chOff x="5258551" y="4747643"/>
             <a:chExt cx="553312" cy="204538"/>
@@ -3619,43 +3772,6 @@
       </p:grpSp>
       <p:pic>
         <p:nvPicPr>
-          <p:cNvPr id="15" name="Picture 14">
-            <a:extLst>
-              <a:ext uri="{FF2B5EF4-FFF2-40B4-BE49-F238E27FC236}">
-                <a16:creationId xmlns:a16="http://schemas.microsoft.com/office/drawing/2014/main" id="{06BC8448-7934-D504-ED85-3E54E07E26DB}"/>
-              </a:ext>
-            </a:extLst>
-          </p:cNvPr>
-          <p:cNvPicPr>
-            <a:picLocks noChangeAspect="1"/>
-          </p:cNvPicPr>
-          <p:nvPr/>
-        </p:nvPicPr>
-        <p:blipFill>
-          <a:blip r:embed="rId2">
-            <a:extLst>
-              <a:ext uri="{28A0092B-C50C-407E-A947-70E740481C1C}">
-                <a14:useLocalDpi xmlns:a14="http://schemas.microsoft.com/office/drawing/2010/main" val="0"/>
-              </a:ext>
-            </a:extLst>
-          </a:blip>
-          <a:srcRect t="77447" r="64775"/>
-          <a:stretch>
-            <a:fillRect/>
-          </a:stretch>
-        </p:blipFill>
-        <p:spPr>
-          <a:xfrm>
-            <a:off x="497305" y="5969668"/>
-            <a:ext cx="4162426" cy="888332"/>
-          </a:xfrm>
-          <a:prstGeom prst="rect">
-            <a:avLst/>
-          </a:prstGeom>
-        </p:spPr>
-      </p:pic>
-      <p:pic>
-        <p:nvPicPr>
           <p:cNvPr id="16" name="Picture 15">
             <a:extLst>
               <a:ext uri="{FF2B5EF4-FFF2-40B4-BE49-F238E27FC236}">
@@ -3683,7 +3799,7 @@
         </p:blipFill>
         <p:spPr>
           <a:xfrm>
-            <a:off x="5783011" y="4753253"/>
+            <a:off x="9711887" y="4793369"/>
             <a:ext cx="367905" cy="171451"/>
           </a:xfrm>
           <a:prstGeom prst="rect">
@@ -3720,7 +3836,7 @@
         </p:blipFill>
         <p:spPr>
           <a:xfrm>
-            <a:off x="6665630" y="4749860"/>
+            <a:off x="10594506" y="4789976"/>
             <a:ext cx="276266" cy="171450"/>
           </a:xfrm>
           <a:prstGeom prst="rect">
@@ -3742,7 +3858,7 @@
         </p:nvGrpSpPr>
         <p:grpSpPr>
           <a:xfrm>
-            <a:off x="6162043" y="4769722"/>
+            <a:off x="10083036" y="4825604"/>
             <a:ext cx="448248" cy="167535"/>
             <a:chOff x="6162043" y="4769722"/>
             <a:chExt cx="448248" cy="167535"/>
@@ -3852,7 +3968,7 @@
         </p:blipFill>
         <p:spPr>
           <a:xfrm>
-            <a:off x="7358234" y="4761014"/>
+            <a:off x="11287110" y="4801130"/>
             <a:ext cx="573601" cy="191589"/>
           </a:xfrm>
           <a:prstGeom prst="rect">
@@ -3965,110 +4081,185 @@
           </a:p>
         </p:txBody>
       </p:sp>
-      <p:pic>
-        <p:nvPicPr>
-          <p:cNvPr id="30" name="Picture 29">
-            <a:extLst>
-              <a:ext uri="{FF2B5EF4-FFF2-40B4-BE49-F238E27FC236}">
-                <a16:creationId xmlns:a16="http://schemas.microsoft.com/office/drawing/2014/main" id="{53966B41-D9ED-6764-BB2D-8847DF7475EF}"/>
-              </a:ext>
-            </a:extLst>
-          </p:cNvPr>
-          <p:cNvPicPr>
-            <a:picLocks noChangeAspect="1"/>
-          </p:cNvPicPr>
+      <p:grpSp>
+        <p:nvGrpSpPr>
+          <p:cNvPr id="24" name="Group 23">
+            <a:extLst>
+              <a:ext uri="{FF2B5EF4-FFF2-40B4-BE49-F238E27FC236}">
+                <a16:creationId xmlns:a16="http://schemas.microsoft.com/office/drawing/2014/main" id="{5354B883-4B13-D289-ADD1-032391EA0A5B}"/>
+              </a:ext>
+            </a:extLst>
+          </p:cNvPr>
+          <p:cNvGrpSpPr/>
           <p:nvPr/>
-        </p:nvPicPr>
-        <p:blipFill>
-          <a:blip r:embed="rId3"/>
-          <a:srcRect l="6805" r="38517"/>
-          <a:stretch>
-            <a:fillRect/>
-          </a:stretch>
-        </p:blipFill>
+        </p:nvGrpSpPr>
+        <p:grpSpPr>
+          <a:xfrm>
+            <a:off x="1032696" y="4264348"/>
+            <a:ext cx="1828800" cy="358072"/>
+            <a:chOff x="8843624" y="4201286"/>
+            <a:chExt cx="1828800" cy="358072"/>
+          </a:xfrm>
+        </p:grpSpPr>
+        <p:pic>
+          <p:nvPicPr>
+            <p:cNvPr id="30" name="Picture 29">
+              <a:extLst>
+                <a:ext uri="{FF2B5EF4-FFF2-40B4-BE49-F238E27FC236}">
+                  <a16:creationId xmlns:a16="http://schemas.microsoft.com/office/drawing/2014/main" id="{53966B41-D9ED-6764-BB2D-8847DF7475EF}"/>
+                </a:ext>
+              </a:extLst>
+            </p:cNvPr>
+            <p:cNvPicPr>
+              <a:picLocks noChangeAspect="1"/>
+            </p:cNvPicPr>
+            <p:nvPr/>
+          </p:nvPicPr>
+          <p:blipFill>
+            <a:blip r:embed="rId3"/>
+            <a:srcRect l="6805" r="38517"/>
+            <a:stretch>
+              <a:fillRect/>
+            </a:stretch>
+          </p:blipFill>
+          <p:spPr>
+            <a:xfrm rot="16200000">
+              <a:off x="9538696" y="3893923"/>
+              <a:ext cx="170494" cy="1160376"/>
+            </a:xfrm>
+            <a:prstGeom prst="rect">
+              <a:avLst/>
+            </a:prstGeom>
+          </p:spPr>
+        </p:pic>
+        <p:sp>
+          <p:nvSpPr>
+            <p:cNvPr id="37" name="TextBox 36">
+              <a:extLst>
+                <a:ext uri="{FF2B5EF4-FFF2-40B4-BE49-F238E27FC236}">
+                  <a16:creationId xmlns:a16="http://schemas.microsoft.com/office/drawing/2014/main" id="{E34A391B-16C4-3D8E-B38A-AC53C8B78F3B}"/>
+                </a:ext>
+              </a:extLst>
+            </p:cNvPr>
+            <p:cNvSpPr txBox="1"/>
+            <p:nvPr/>
+          </p:nvSpPr>
+          <p:spPr>
+            <a:xfrm>
+              <a:off x="9758024" y="4201286"/>
+              <a:ext cx="914400" cy="215444"/>
+            </a:xfrm>
+            <a:prstGeom prst="rect">
+              <a:avLst/>
+            </a:prstGeom>
+            <a:noFill/>
+          </p:spPr>
+          <p:txBody>
+            <a:bodyPr wrap="square" rtlCol="0">
+              <a:spAutoFit/>
+            </a:bodyPr>
+            <a:lstStyle/>
+            <a:p>
+              <a:r>
+                <a:rPr lang="en-US" sz="800" dirty="0">
+                  <a:latin typeface="Helvetica" panose="020B0604020202020204" pitchFamily="34" charset="0"/>
+                  <a:cs typeface="Helvetica" panose="020B0604020202020204" pitchFamily="34" charset="0"/>
+                </a:rPr>
+                <a:t>NC warmer</a:t>
+              </a:r>
+            </a:p>
+          </p:txBody>
+        </p:sp>
+        <p:sp>
+          <p:nvSpPr>
+            <p:cNvPr id="38" name="TextBox 37">
+              <a:extLst>
+                <a:ext uri="{FF2B5EF4-FFF2-40B4-BE49-F238E27FC236}">
+                  <a16:creationId xmlns:a16="http://schemas.microsoft.com/office/drawing/2014/main" id="{23105D28-3712-BDD1-C547-D0980DBCA1D8}"/>
+                </a:ext>
+              </a:extLst>
+            </p:cNvPr>
+            <p:cNvSpPr txBox="1"/>
+            <p:nvPr/>
+          </p:nvSpPr>
+          <p:spPr>
+            <a:xfrm>
+              <a:off x="8843624" y="4201286"/>
+              <a:ext cx="914400" cy="215444"/>
+            </a:xfrm>
+            <a:prstGeom prst="rect">
+              <a:avLst/>
+            </a:prstGeom>
+            <a:noFill/>
+          </p:spPr>
+          <p:txBody>
+            <a:bodyPr wrap="square" rtlCol="0">
+              <a:spAutoFit/>
+            </a:bodyPr>
+            <a:lstStyle/>
+            <a:p>
+              <a:r>
+                <a:rPr lang="en-US" sz="800" dirty="0">
+                  <a:latin typeface="Helvetica" panose="020B0604020202020204" pitchFamily="34" charset="0"/>
+                  <a:cs typeface="Helvetica" panose="020B0604020202020204" pitchFamily="34" charset="0"/>
+                </a:rPr>
+                <a:t>NC colder</a:t>
+              </a:r>
+            </a:p>
+          </p:txBody>
+        </p:sp>
+      </p:grpSp>
+      <p:sp>
+        <p:nvSpPr>
+          <p:cNvPr id="23" name="Rectangle 22">
+            <a:extLst>
+              <a:ext uri="{FF2B5EF4-FFF2-40B4-BE49-F238E27FC236}">
+                <a16:creationId xmlns:a16="http://schemas.microsoft.com/office/drawing/2014/main" id="{28730940-257D-650F-95A5-11A753CB7509}"/>
+              </a:ext>
+            </a:extLst>
+          </p:cNvPr>
+          <p:cNvSpPr/>
+          <p:nvPr/>
+        </p:nvSpPr>
         <p:spPr>
-          <a:xfrm rot="16200000">
-            <a:off x="9538696" y="3893923"/>
-            <a:ext cx="170494" cy="1160376"/>
+          <a:xfrm>
+            <a:off x="4359166" y="3290636"/>
+            <a:ext cx="130069" cy="138364"/>
           </a:xfrm>
           <a:prstGeom prst="rect">
             <a:avLst/>
           </a:prstGeom>
+          <a:solidFill>
+            <a:schemeClr val="bg1"/>
+          </a:solidFill>
+          <a:ln>
+            <a:solidFill>
+              <a:schemeClr val="bg1"/>
+            </a:solidFill>
+          </a:ln>
         </p:spPr>
-      </p:pic>
-      <p:sp>
-        <p:nvSpPr>
-          <p:cNvPr id="37" name="TextBox 36">
-            <a:extLst>
-              <a:ext uri="{FF2B5EF4-FFF2-40B4-BE49-F238E27FC236}">
-                <a16:creationId xmlns:a16="http://schemas.microsoft.com/office/drawing/2014/main" id="{E34A391B-16C4-3D8E-B38A-AC53C8B78F3B}"/>
-              </a:ext>
-            </a:extLst>
-          </p:cNvPr>
-          <p:cNvSpPr txBox="1"/>
-          <p:nvPr/>
-        </p:nvSpPr>
-        <p:spPr>
-          <a:xfrm>
-            <a:off x="9758024" y="4201286"/>
-            <a:ext cx="914400" cy="215444"/>
-          </a:xfrm>
-          <a:prstGeom prst="rect">
-            <a:avLst/>
-          </a:prstGeom>
-          <a:noFill/>
-        </p:spPr>
-        <p:txBody>
-          <a:bodyPr wrap="square" rtlCol="0">
-            <a:spAutoFit/>
-          </a:bodyPr>
-          <a:lstStyle/>
-          <a:p>
-            <a:r>
-              <a:rPr lang="en-US" sz="800" dirty="0">
-                <a:latin typeface="Helvetica" panose="020B0604020202020204" pitchFamily="34" charset="0"/>
-                <a:cs typeface="Helvetica" panose="020B0604020202020204" pitchFamily="34" charset="0"/>
-              </a:rPr>
-              <a:t>NC warmer</a:t>
-            </a:r>
-          </a:p>
-        </p:txBody>
-      </p:sp>
-      <p:sp>
-        <p:nvSpPr>
-          <p:cNvPr id="38" name="TextBox 37">
-            <a:extLst>
-              <a:ext uri="{FF2B5EF4-FFF2-40B4-BE49-F238E27FC236}">
-                <a16:creationId xmlns:a16="http://schemas.microsoft.com/office/drawing/2014/main" id="{23105D28-3712-BDD1-C547-D0980DBCA1D8}"/>
-              </a:ext>
-            </a:extLst>
-          </p:cNvPr>
-          <p:cNvSpPr txBox="1"/>
-          <p:nvPr/>
-        </p:nvSpPr>
-        <p:spPr>
-          <a:xfrm>
-            <a:off x="8843624" y="4201286"/>
-            <a:ext cx="914400" cy="215444"/>
-          </a:xfrm>
-          <a:prstGeom prst="rect">
-            <a:avLst/>
-          </a:prstGeom>
-          <a:noFill/>
-        </p:spPr>
-        <p:txBody>
-          <a:bodyPr wrap="square" rtlCol="0">
-            <a:spAutoFit/>
-          </a:bodyPr>
-          <a:lstStyle/>
-          <a:p>
-            <a:r>
-              <a:rPr lang="en-US" sz="800" dirty="0">
-                <a:latin typeface="Helvetica" panose="020B0604020202020204" pitchFamily="34" charset="0"/>
-                <a:cs typeface="Helvetica" panose="020B0604020202020204" pitchFamily="34" charset="0"/>
-              </a:rPr>
-              <a:t>NC colder</a:t>
-            </a:r>
+        <p:style>
+          <a:lnRef idx="2">
+            <a:schemeClr val="accent1">
+              <a:shade val="15000"/>
+            </a:schemeClr>
+          </a:lnRef>
+          <a:fillRef idx="1">
+            <a:schemeClr val="accent1"/>
+          </a:fillRef>
+          <a:effectRef idx="0">
+            <a:schemeClr val="accent1"/>
+          </a:effectRef>
+          <a:fontRef idx="minor">
+            <a:schemeClr val="lt1"/>
+          </a:fontRef>
+        </p:style>
+        <p:txBody>
+          <a:bodyPr rtlCol="0" anchor="ctr"/>
+          <a:lstStyle/>
+          <a:p>
+            <a:pPr algn="ctr"/>
+            <a:endParaRPr lang="en-US"/>
           </a:p>
         </p:txBody>
       </p:sp>

</xml_diff>

<commit_message>
figure 1 update, modify supplemental tables
</commit_message>
<xml_diff>
--- a/figures/ch1_figures.pptx
+++ b/figures/ch1_figures.pptx
@@ -6,8 +6,9 @@
   </p:sldMasterIdLst>
   <p:sldIdLst>
     <p:sldId id="256" r:id="rId2"/>
-    <p:sldId id="258" r:id="rId3"/>
-    <p:sldId id="259" r:id="rId4"/>
+    <p:sldId id="261" r:id="rId3"/>
+    <p:sldId id="258" r:id="rId4"/>
+    <p:sldId id="259" r:id="rId5"/>
   </p:sldIdLst>
   <p:sldSz cx="12192000" cy="6858000"/>
   <p:notesSz cx="6858000" cy="9144000"/>
@@ -261,7 +262,7 @@
           <a:p>
             <a:fld id="{6AECCEE4-E404-41DF-89A3-E64313283A40}" type="datetimeFigureOut">
               <a:rPr lang="en-US" smtClean="0"/>
-              <a:t>6/18/2026</a:t>
+              <a:t>6/23/2026</a:t>
             </a:fld>
             <a:endParaRPr lang="en-US"/>
           </a:p>
@@ -459,7 +460,7 @@
           <a:p>
             <a:fld id="{6AECCEE4-E404-41DF-89A3-E64313283A40}" type="datetimeFigureOut">
               <a:rPr lang="en-US" smtClean="0"/>
-              <a:t>6/18/2026</a:t>
+              <a:t>6/23/2026</a:t>
             </a:fld>
             <a:endParaRPr lang="en-US"/>
           </a:p>
@@ -667,7 +668,7 @@
           <a:p>
             <a:fld id="{6AECCEE4-E404-41DF-89A3-E64313283A40}" type="datetimeFigureOut">
               <a:rPr lang="en-US" smtClean="0"/>
-              <a:t>6/18/2026</a:t>
+              <a:t>6/23/2026</a:t>
             </a:fld>
             <a:endParaRPr lang="en-US"/>
           </a:p>
@@ -865,7 +866,7 @@
           <a:p>
             <a:fld id="{6AECCEE4-E404-41DF-89A3-E64313283A40}" type="datetimeFigureOut">
               <a:rPr lang="en-US" smtClean="0"/>
-              <a:t>6/18/2026</a:t>
+              <a:t>6/23/2026</a:t>
             </a:fld>
             <a:endParaRPr lang="en-US"/>
           </a:p>
@@ -1140,7 +1141,7 @@
           <a:p>
             <a:fld id="{6AECCEE4-E404-41DF-89A3-E64313283A40}" type="datetimeFigureOut">
               <a:rPr lang="en-US" smtClean="0"/>
-              <a:t>6/18/2026</a:t>
+              <a:t>6/23/2026</a:t>
             </a:fld>
             <a:endParaRPr lang="en-US"/>
           </a:p>
@@ -1405,7 +1406,7 @@
           <a:p>
             <a:fld id="{6AECCEE4-E404-41DF-89A3-E64313283A40}" type="datetimeFigureOut">
               <a:rPr lang="en-US" smtClean="0"/>
-              <a:t>6/18/2026</a:t>
+              <a:t>6/23/2026</a:t>
             </a:fld>
             <a:endParaRPr lang="en-US"/>
           </a:p>
@@ -1817,7 +1818,7 @@
           <a:p>
             <a:fld id="{6AECCEE4-E404-41DF-89A3-E64313283A40}" type="datetimeFigureOut">
               <a:rPr lang="en-US" smtClean="0"/>
-              <a:t>6/18/2026</a:t>
+              <a:t>6/23/2026</a:t>
             </a:fld>
             <a:endParaRPr lang="en-US"/>
           </a:p>
@@ -1958,7 +1959,7 @@
           <a:p>
             <a:fld id="{6AECCEE4-E404-41DF-89A3-E64313283A40}" type="datetimeFigureOut">
               <a:rPr lang="en-US" smtClean="0"/>
-              <a:t>6/18/2026</a:t>
+              <a:t>6/23/2026</a:t>
             </a:fld>
             <a:endParaRPr lang="en-US"/>
           </a:p>
@@ -2071,7 +2072,7 @@
           <a:p>
             <a:fld id="{6AECCEE4-E404-41DF-89A3-E64313283A40}" type="datetimeFigureOut">
               <a:rPr lang="en-US" smtClean="0"/>
-              <a:t>6/18/2026</a:t>
+              <a:t>6/23/2026</a:t>
             </a:fld>
             <a:endParaRPr lang="en-US"/>
           </a:p>
@@ -2382,7 +2383,7 @@
           <a:p>
             <a:fld id="{6AECCEE4-E404-41DF-89A3-E64313283A40}" type="datetimeFigureOut">
               <a:rPr lang="en-US" smtClean="0"/>
-              <a:t>6/18/2026</a:t>
+              <a:t>6/23/2026</a:t>
             </a:fld>
             <a:endParaRPr lang="en-US"/>
           </a:p>
@@ -2670,7 +2671,7 @@
           <a:p>
             <a:fld id="{6AECCEE4-E404-41DF-89A3-E64313283A40}" type="datetimeFigureOut">
               <a:rPr lang="en-US" smtClean="0"/>
-              <a:t>6/18/2026</a:t>
+              <a:t>6/23/2026</a:t>
             </a:fld>
             <a:endParaRPr lang="en-US"/>
           </a:p>
@@ -2911,7 +2912,7 @@
           <a:p>
             <a:fld id="{6AECCEE4-E404-41DF-89A3-E64313283A40}" type="datetimeFigureOut">
               <a:rPr lang="en-US" smtClean="0"/>
-              <a:t>6/18/2026</a:t>
+              <a:t>6/23/2026</a:t>
             </a:fld>
             <a:endParaRPr lang="en-US"/>
           </a:p>
@@ -4283,6 +4284,153 @@
   <p:cSld>
     <p:spTree>
       <p:nvGrpSpPr>
+        <p:cNvPr id="1" name="">
+          <a:extLst>
+            <a:ext uri="{FF2B5EF4-FFF2-40B4-BE49-F238E27FC236}">
+              <a16:creationId xmlns:a16="http://schemas.microsoft.com/office/drawing/2014/main" id="{F0A0D1B8-6604-F374-3574-3761BBE5B1A6}"/>
+            </a:ext>
+          </a:extLst>
+        </p:cNvPr>
+        <p:cNvGrpSpPr/>
+        <p:nvPr/>
+      </p:nvGrpSpPr>
+      <p:grpSpPr>
+        <a:xfrm>
+          <a:off x="0" y="0"/>
+          <a:ext cx="0" cy="0"/>
+          <a:chOff x="0" y="0"/>
+          <a:chExt cx="0" cy="0"/>
+        </a:xfrm>
+      </p:grpSpPr>
+      <p:pic>
+        <p:nvPicPr>
+          <p:cNvPr id="3" name="Picture 2">
+            <a:extLst>
+              <a:ext uri="{FF2B5EF4-FFF2-40B4-BE49-F238E27FC236}">
+                <a16:creationId xmlns:a16="http://schemas.microsoft.com/office/drawing/2014/main" id="{882E1A7C-28F8-A552-8881-F1A620CCBF49}"/>
+              </a:ext>
+            </a:extLst>
+          </p:cNvPr>
+          <p:cNvPicPr>
+            <a:picLocks noChangeAspect="1"/>
+          </p:cNvPicPr>
+          <p:nvPr/>
+        </p:nvPicPr>
+        <p:blipFill>
+          <a:blip r:embed="rId2">
+            <a:extLst>
+              <a:ext uri="{28A0092B-C50C-407E-A947-70E740481C1C}">
+                <a14:useLocalDpi xmlns:a14="http://schemas.microsoft.com/office/drawing/2010/main" val="0"/>
+              </a:ext>
+            </a:extLst>
+          </a:blip>
+          <a:srcRect/>
+          <a:stretch/>
+        </p:blipFill>
+        <p:spPr>
+          <a:xfrm>
+            <a:off x="2238375" y="0"/>
+            <a:ext cx="7715250" cy="6858000"/>
+          </a:xfrm>
+          <a:prstGeom prst="rect">
+            <a:avLst/>
+          </a:prstGeom>
+        </p:spPr>
+      </p:pic>
+      <p:pic>
+        <p:nvPicPr>
+          <p:cNvPr id="4" name="Picture 3">
+            <a:extLst>
+              <a:ext uri="{FF2B5EF4-FFF2-40B4-BE49-F238E27FC236}">
+                <a16:creationId xmlns:a16="http://schemas.microsoft.com/office/drawing/2014/main" id="{25B6F819-F465-0917-E668-A398FD637C3A}"/>
+              </a:ext>
+            </a:extLst>
+          </p:cNvPr>
+          <p:cNvPicPr>
+            <a:picLocks noChangeAspect="1"/>
+          </p:cNvPicPr>
+          <p:nvPr/>
+        </p:nvPicPr>
+        <p:blipFill>
+          <a:blip r:embed="rId3">
+            <a:alphaModFix/>
+            <a:extLst>
+              <a:ext uri="{28A0092B-C50C-407E-A947-70E740481C1C}">
+                <a14:useLocalDpi xmlns:a14="http://schemas.microsoft.com/office/drawing/2010/main" val="0"/>
+              </a:ext>
+            </a:extLst>
+          </a:blip>
+          <a:srcRect l="37689" t="27752" r="52940" b="20620"/>
+          <a:stretch>
+            <a:fillRect/>
+          </a:stretch>
+        </p:blipFill>
+        <p:spPr>
+          <a:xfrm>
+            <a:off x="9263529" y="5014128"/>
+            <a:ext cx="151776" cy="381378"/>
+          </a:xfrm>
+          <a:prstGeom prst="rect">
+            <a:avLst/>
+          </a:prstGeom>
+        </p:spPr>
+      </p:pic>
+      <p:pic>
+        <p:nvPicPr>
+          <p:cNvPr id="5" name="Picture 4">
+            <a:extLst>
+              <a:ext uri="{FF2B5EF4-FFF2-40B4-BE49-F238E27FC236}">
+                <a16:creationId xmlns:a16="http://schemas.microsoft.com/office/drawing/2014/main" id="{FBCFA825-F09A-7062-A332-3E9ADD2C23FD}"/>
+              </a:ext>
+            </a:extLst>
+          </p:cNvPr>
+          <p:cNvPicPr>
+            <a:picLocks noChangeAspect="1"/>
+          </p:cNvPicPr>
+          <p:nvPr/>
+        </p:nvPicPr>
+        <p:blipFill>
+          <a:blip r:embed="rId3">
+            <a:alphaModFix/>
+            <a:extLst>
+              <a:ext uri="{28A0092B-C50C-407E-A947-70E740481C1C}">
+                <a14:useLocalDpi xmlns:a14="http://schemas.microsoft.com/office/drawing/2010/main" val="0"/>
+              </a:ext>
+            </a:extLst>
+          </a:blip>
+          <a:srcRect l="37689" t="27752" r="52940" b="20620"/>
+          <a:stretch>
+            <a:fillRect/>
+          </a:stretch>
+        </p:blipFill>
+        <p:spPr>
+          <a:xfrm>
+            <a:off x="9263529" y="1584275"/>
+            <a:ext cx="151776" cy="381378"/>
+          </a:xfrm>
+          <a:prstGeom prst="rect">
+            <a:avLst/>
+          </a:prstGeom>
+        </p:spPr>
+      </p:pic>
+    </p:spTree>
+    <p:extLst>
+      <p:ext uri="{BB962C8B-B14F-4D97-AF65-F5344CB8AC3E}">
+        <p14:creationId xmlns:p14="http://schemas.microsoft.com/office/powerpoint/2010/main" val="2294755368"/>
+      </p:ext>
+    </p:extLst>
+  </p:cSld>
+  <p:clrMapOvr>
+    <a:masterClrMapping/>
+  </p:clrMapOvr>
+</p:sld>
+</file>
+
+<file path=ppt/slides/slide3.xml><?xml version="1.0" encoding="utf-8"?>
+<p:sld xmlns:a="http://schemas.openxmlformats.org/drawingml/2006/main" xmlns:r="http://schemas.openxmlformats.org/officeDocument/2006/relationships" xmlns:p="http://schemas.openxmlformats.org/presentationml/2006/main">
+  <p:cSld>
+    <p:spTree>
+      <p:nvGrpSpPr>
         <p:cNvPr id="1" name=""/>
         <p:cNvGrpSpPr/>
         <p:nvPr/>
@@ -4420,7 +4568,7 @@
 </p:sld>
 </file>
 
-<file path=ppt/slides/slide3.xml><?xml version="1.0" encoding="utf-8"?>
+<file path=ppt/slides/slide4.xml><?xml version="1.0" encoding="utf-8"?>
 <p:sld xmlns:a="http://schemas.openxmlformats.org/drawingml/2006/main" xmlns:r="http://schemas.openxmlformats.org/officeDocument/2006/relationships" xmlns:p="http://schemas.openxmlformats.org/presentationml/2006/main">
   <p:cSld>
     <p:spTree>

</xml_diff>